<commit_message>
Update contributions and add AI-use statement
</commit_message>
<xml_diff>
--- a/slides/MIRAGE_presentation.pptx
+++ b/slides/MIRAGE_presentation.pptx
@@ -120,23 +120,23 @@
   <p:extLst>
     <p:ext uri="{521415D9-36F7-43E2-AB2F-B90AF26B5E84}">
       <p14:sectionLst xmlns:p14="http://schemas.microsoft.com/office/powerpoint/2010/main">
-        <p14:section name="Opening" id="{7981af0f-b7a3-fcf3-a4e7-a1464322e0b5}">
+        <p14:section name="Opening" id="{ac2659eb-1df3-d732-4da9-0c97d6115530}">
           <p14:sldIdLst>
             <p14:sldId id="256"/>
           </p14:sldIdLst>
         </p14:section>
-        <p14:section name="Problem and questions" id="{447149ee-9cc7-af54-0db3-5df20712bcab}">
+        <p14:section name="Problem and questions" id="{538faeed-cb75-3582-774a-6bc80026b71e}">
           <p14:sldIdLst>
             <p14:sldId id="257"/>
             <p14:sldId id="258"/>
           </p14:sldIdLst>
         </p14:section>
-        <p14:section name="Methods" id="{67cf251e-9ea2-3d69-50db-aea754cb1c57}">
+        <p14:section name="Methods" id="{a7bc12c1-55a7-54b0-874a-e9a197085cbc}">
           <p14:sldIdLst>
             <p14:sldId id="259"/>
           </p14:sldIdLst>
         </p14:section>
-        <p14:section name="Results" id="{1332fecc-a13a-3c06-572e-f556f57e6f2d}">
+        <p14:section name="Results" id="{83300e6f-5a68-0edc-977d-cf428f02c5fd}">
           <p14:sldIdLst>
             <p14:sldId id="260"/>
             <p14:sldId id="261"/>
@@ -147,13 +147,13 @@
             <p14:sldId id="266"/>
           </p14:sldIdLst>
         </p14:section>
-        <p14:section name="Discussion" id="{81d891dd-4361-0660-0353-8599f2efa491}">
+        <p14:section name="Discussion" id="{a2257713-1c35-f725-5233-2e27dc9b4340}">
           <p14:sldIdLst>
             <p14:sldId id="267"/>
             <p14:sldId id="268"/>
           </p14:sldIdLst>
         </p14:section>
-        <p14:section name="Closing" id="{87d0d3fb-4482-83c7-2b74-793308b1c253}">
+        <p14:section name="Closing" id="{41c39dd7-e64c-3e0d-deda-d26e9233d478}">
           <p14:sldIdLst>
             <p14:sldId id="269"/>
           </p14:sldIdLst>
@@ -4680,7 +4680,7 @@
                   <a:schemeClr val="tx2"/>
                 </a:solidFill>
               </a:rPr>
-              <a:t>Vedant Abhangrao</a:t>
+              <a:t>Nilay Shahapure</a:t>
             </a:r>
             <a:endParaRPr lang="en-US" sz="1400" dirty="0"/>
           </a:p>
@@ -4719,7 +4719,7 @@
                   <a:schemeClr val="tx1"/>
                 </a:solidFill>
               </a:rPr>
-              <a:t>Search strategy, screening log, mandate search</a:t>
+              <a:t>Analysis (harmonisation, statistics, figures); report, supplementary document, presentation</a:t>
             </a:r>
             <a:endParaRPr lang="en-US" sz="1150" dirty="0"/>
           </a:p>
@@ -4782,7 +4782,7 @@
                   <a:schemeClr val="tx2"/>
                 </a:solidFill>
               </a:rPr>
-              <a:t>Nilay Shahapure</a:t>
+              <a:t>Vedant Abhangrao</a:t>
             </a:r>
             <a:endParaRPr lang="en-US" sz="1400" dirty="0"/>
           </a:p>
@@ -4821,7 +4821,7 @@
                   <a:schemeClr val="tx1"/>
                 </a:solidFill>
               </a:rPr>
-              <a:t>Data harmonisation, analysis code, figures, supplementary document</a:t>
+              <a:t>Analysis (screening rules, evidence grading, cost method, reconciliation)</a:t>
             </a:r>
             <a:endParaRPr lang="en-US" sz="1150" dirty="0"/>
           </a:p>
@@ -4923,7 +4923,7 @@
                   <a:schemeClr val="tx1"/>
                 </a:solidFill>
               </a:rPr>
-              <a:t>Cost and benchmark search, deflation, levelised cost</a:t>
+              <a:t>Sourcing: locating documents, extracting source records</a:t>
             </a:r>
             <a:endParaRPr lang="en-US" sz="1150" dirty="0"/>
           </a:p>
@@ -5025,7 +5025,7 @@
                   <a:schemeClr val="tx1"/>
                 </a:solidFill>
               </a:rPr>
-              <a:t>Functionality and failure-mode search, report, presentation</a:t>
+              <a:t>Sourcing: locating documents, extracting source records</a:t>
             </a:r>
             <a:endParaRPr lang="en-US" sz="1150" dirty="0"/>
           </a:p>
@@ -5127,7 +5127,7 @@
                   <a:schemeClr val="tx1"/>
                 </a:solidFill>
               </a:rPr>
-              <a:t>Report (2 pages, IMRaD) and Supplementary Information (15 pages: full tables, screening log, midway reconciliation, 168 source URLs)</a:t>
+              <a:t>Report (2 pages, IMRaD) and Supplementary Information (15 pages: full tables, screening log, reconciliation with the mid-term report, 168 source URLs)</a:t>
             </a:r>
             <a:endParaRPr lang="en-US" sz="1150" dirty="0"/>
           </a:p>
@@ -5153,7 +5153,7 @@
                   <a:schemeClr val="tx1"/>
                 </a:solidFill>
               </a:rPr>
-              <a:t>Data: harmonised dataset for performance, cost, functionality, installation, failure modes and mandates; source extraction tables with a URL and verbatim quote for every number</a:t>
+              <a:t>Data: harmonised dataset for performance, cost, functionality, installation, failure modes and mandates; source extraction tables with a URL and the quoted values for every number</a:t>
             </a:r>
             <a:endParaRPr lang="en-US" sz="1150" dirty="0"/>
           </a:p>
@@ -5205,7 +5205,33 @@
                   <a:schemeClr val="tx1"/>
                 </a:solidFill>
               </a:rPr>
-              <a:t>Every number in the report is traceable to a source URL and a verbatim quote.</a:t>
+              <a:t>Every number in the report is traceable to a source URL and the sentence or values taken from the page.</a:t>
+            </a:r>
+            <a:endParaRPr lang="en-US" sz="1150" dirty="0"/>
+          </a:p>
+          <a:p>
+            <a:pPr indent="0" marL="0">
+              <a:spcAft>
+                <a:spcPts val="400"/>
+              </a:spcAft>
+              <a:buNone/>
+            </a:pPr>
+            <a:endParaRPr lang="en-US" sz="1150" dirty="0"/>
+          </a:p>
+          <a:p>
+            <a:pPr indent="0" marL="0">
+              <a:spcAft>
+                <a:spcPts val="400"/>
+              </a:spcAft>
+              <a:buNone/>
+            </a:pPr>
+            <a:r>
+              <a:rPr lang="en-US" sz="1150" dirty="0">
+                <a:solidFill>
+                  <a:schemeClr val="tx1"/>
+                </a:solidFill>
+              </a:rPr>
+              <a:t>Code repository: github.com/nilay-shahapure/MIRAGE_CM617</a:t>
             </a:r>
             <a:endParaRPr lang="en-US" sz="1150" dirty="0"/>
           </a:p>
@@ -5244,7 +5270,7 @@
                   <a:schemeClr val="accent4"/>
                 </a:solidFill>
               </a:rPr>
-              <a:t>All four members extracted records and cross-checked each other's rows against the source quotes.</a:t>
+              <a:t>AI tools helped with code, figures, searches and drafting; the statement is in the Supplementary Information.</a:t>
             </a:r>
             <a:endParaRPr lang="en-US" sz="950" dirty="0"/>
           </a:p>

</xml_diff>

<commit_message>
Contributions: add video presentation and voice-over to Vedant
</commit_message>
<xml_diff>
--- a/slides/MIRAGE_presentation.pptx
+++ b/slides/MIRAGE_presentation.pptx
@@ -120,23 +120,23 @@
   <p:extLst>
     <p:ext uri="{521415D9-36F7-43E2-AB2F-B90AF26B5E84}">
       <p14:sectionLst xmlns:p14="http://schemas.microsoft.com/office/powerpoint/2010/main">
-        <p14:section name="Opening" id="{ac2659eb-1df3-d732-4da9-0c97d6115530}">
+        <p14:section name="Opening" id="{89989d0b-98e5-f724-8c1c-94d7662ee0bd}">
           <p14:sldIdLst>
             <p14:sldId id="256"/>
           </p14:sldIdLst>
         </p14:section>
-        <p14:section name="Problem and questions" id="{538faeed-cb75-3582-774a-6bc80026b71e}">
+        <p14:section name="Problem and questions" id="{5fe46e85-3b0f-95c9-877f-8c5ecd3c26a2}">
           <p14:sldIdLst>
             <p14:sldId id="257"/>
             <p14:sldId id="258"/>
           </p14:sldIdLst>
         </p14:section>
-        <p14:section name="Methods" id="{a7bc12c1-55a7-54b0-874a-e9a197085cbc}">
+        <p14:section name="Methods" id="{14ac669a-a231-0601-34d0-9f103b9e35dd}">
           <p14:sldIdLst>
             <p14:sldId id="259"/>
           </p14:sldIdLst>
         </p14:section>
-        <p14:section name="Results" id="{83300e6f-5a68-0edc-977d-cf428f02c5fd}">
+        <p14:section name="Results" id="{bb9c4393-9cab-f05c-d2a5-0f2f6bc6e5b2}">
           <p14:sldIdLst>
             <p14:sldId id="260"/>
             <p14:sldId id="261"/>
@@ -147,13 +147,13 @@
             <p14:sldId id="266"/>
           </p14:sldIdLst>
         </p14:section>
-        <p14:section name="Discussion" id="{a2257713-1c35-f725-5233-2e27dc9b4340}">
+        <p14:section name="Discussion" id="{4dc0ec9d-ce8b-2d99-7348-915016fd54eb}">
           <p14:sldIdLst>
             <p14:sldId id="267"/>
             <p14:sldId id="268"/>
           </p14:sldIdLst>
         </p14:section>
-        <p14:section name="Closing" id="{41c39dd7-e64c-3e0d-deda-d26e9233d478}">
+        <p14:section name="Closing" id="{f5d76b64-ff4f-0555-67c8-496b39c50b9c}">
           <p14:sldIdLst>
             <p14:sldId id="269"/>
           </p14:sldIdLst>
@@ -4821,7 +4821,7 @@
                   <a:schemeClr val="tx1"/>
                 </a:solidFill>
               </a:rPr>
-              <a:t>Analysis (screening rules, evidence grading, cost method, reconciliation)</a:t>
+              <a:t>Analysis (screening rules, evidence grading, cost method, reconciliation); video presentation and voice-over</a:t>
             </a:r>
             <a:endParaRPr lang="en-US" sz="1150" dirty="0"/>
           </a:p>

</xml_diff>